<commit_message>
Tag code Try-It item in Lesson 4
Audited the simulation deck against its lesson doc — code coverage was
already complete, no missing slides. Tag the one Try-It item that
involves writing real code (logging applied volts inside
simulatePeriodic()) with the WRITE CODE pill in the deck and a bold Code
lead-in in the lesson doc. The other two items are single-value tweaks
(inertia, step input) and stay untagged per the established convention.
</commit_message>
<xml_diff>
--- a/docs/presentations/v3/04-simulation.pptx
+++ b/docs/presentations/v3/04-simulation.pptx
@@ -2558,7 +2558,7 @@
         <p:spPr>
           <a:xfrm>
             <a:off x="1600200" y="4251960"/>
-            <a:ext cx="4023360" cy="457200"/>
+            <a:ext cx="2606040" cy="457200"/>
           </a:xfrm>
           <a:prstGeom prst="rect">
             <a:avLst/>
@@ -2593,7 +2593,68 @@
       </p:sp>
       <p:sp>
         <p:nvSpPr>
-          <p:cNvPr id="20" name="Text 17"/>
+          <p:cNvPr id="20" name="Shape 17"/>
+          <p:cNvSpPr/>
+          <p:nvPr/>
+        </p:nvSpPr>
+        <p:spPr>
+          <a:xfrm>
+            <a:off x="4206240" y="4334256"/>
+            <a:ext cx="1417320" cy="292608"/>
+          </a:xfrm>
+          <a:prstGeom prst="roundRect">
+            <a:avLst>
+              <a:gd name="adj" fmla="val 18750"/>
+            </a:avLst>
+          </a:prstGeom>
+          <a:solidFill>
+            <a:srgbClr val="FF5010"/>
+          </a:solidFill>
+          <a:ln/>
+        </p:spPr>
+      </p:sp>
+      <p:sp>
+        <p:nvSpPr>
+          <p:cNvPr id="21" name="Text 18"/>
+          <p:cNvSpPr/>
+          <p:nvPr/>
+        </p:nvSpPr>
+        <p:spPr>
+          <a:xfrm>
+            <a:off x="4206240" y="4334256"/>
+            <a:ext cx="1417320" cy="292608"/>
+          </a:xfrm>
+          <a:prstGeom prst="rect">
+            <a:avLst/>
+          </a:prstGeom>
+          <a:noFill/>
+          <a:ln/>
+        </p:spPr>
+        <p:txBody>
+          <a:bodyPr wrap="square" lIns="0" tIns="0" rIns="0" bIns="0" rtlCol="0" anchor="ctr"/>
+          <a:lstStyle/>
+          <a:p>
+            <a:pPr algn="ctr" indent="0" marL="0">
+              <a:buNone/>
+            </a:pPr>
+            <a:r>
+              <a:rPr lang="en-US" sz="1200" b="1" spc="50" kern="0" dirty="0">
+                <a:solidFill>
+                  <a:srgbClr val="0B1F3A"/>
+                </a:solidFill>
+                <a:latin typeface="Calibri" pitchFamily="34" charset="0"/>
+                <a:ea typeface="Calibri" pitchFamily="34" charset="-122"/>
+                <a:cs typeface="Calibri" pitchFamily="34" charset="-120"/>
+              </a:rPr>
+              <a:t>WRITE CODE</a:t>
+            </a:r>
+            <a:endParaRPr lang="en-US" sz="1200" dirty="0"/>
+          </a:p>
+        </p:txBody>
+      </p:sp>
+      <p:sp>
+        <p:nvSpPr>
+          <p:cNvPr id="22" name="Text 19"/>
           <p:cNvSpPr/>
           <p:nvPr/>
         </p:nvSpPr>
@@ -2635,7 +2696,7 @@
       </p:sp>
       <p:sp>
         <p:nvSpPr>
-          <p:cNvPr id="21" name="Text 18"/>
+          <p:cNvPr id="23" name="Text 20"/>
           <p:cNvSpPr/>
           <p:nvPr/>
         </p:nvSpPr>
@@ -2674,7 +2735,7 @@
       </p:sp>
       <p:sp>
         <p:nvSpPr>
-          <p:cNvPr id="22" name="Text 19"/>
+          <p:cNvPr id="24" name="Text 21"/>
           <p:cNvSpPr/>
           <p:nvPr/>
         </p:nvSpPr>
@@ -2713,7 +2774,7 @@
       </p:sp>
       <p:pic>
         <p:nvPicPr>
-          <p:cNvPr id="23" name="Image 1" descr="/home/user/BasicRobotLessons/docs/presentations/v3/template/assets/logo/team5010-logo-onnavy.png">    </p:cNvPr>
+          <p:cNvPr id="25" name="Image 1" descr="/home/user/BasicRobotLessons/docs/presentations/v3/template/assets/logo/team5010-logo-onnavy.png">    </p:cNvPr>
           <p:cNvPicPr>
             <a:picLocks noChangeAspect="1"/>
           </p:cNvPicPr>

</xml_diff>